<commit_message>
Update Review 1 slides with 3 of 3 tests passing
</commit_message>
<xml_diff>
--- a/docs/review1.pptx
+++ b/docs/review1.pptx
@@ -116,27 +116,27 @@
   <p:extLst>
     <p:ext uri="{521415D9-36F7-43E2-AB2F-B90AF26B5E84}">
       <p14:sectionLst xmlns:p14="http://schemas.microsoft.com/office/powerpoint/2010/main">
-        <p14:section name="Introduction" id="{57c83825-4df3-ad31-bb31-0d316cd76592}">
+        <p14:section name="Introduction" id="{4418caf4-680b-6024-b35b-1ed633ae5d1d}">
           <p14:sldIdLst>
             <p14:sldId id="256"/>
             <p14:sldId id="257"/>
             <p14:sldId id="258"/>
           </p14:sldIdLst>
         </p14:section>
-        <p14:section name="Background" id="{3bdc46f5-01b5-e308-8a24-bc2dcacf10bd}">
+        <p14:section name="Background" id="{290c39b4-51f5-fac6-41a9-86b1ed4e917b}">
           <p14:sldIdLst>
             <p14:sldId id="259"/>
             <p14:sldId id="260"/>
           </p14:sldIdLst>
         </p14:section>
-        <p14:section name="Design" id="{797f8180-cbab-feaa-f4d7-db9dc3a13ddf}">
+        <p14:section name="Design" id="{c801d24d-d741-0486-2670-2d2e307ef3e3}">
           <p14:sldIdLst>
             <p14:sldId id="261"/>
             <p14:sldId id="262"/>
             <p14:sldId id="263"/>
           </p14:sldIdLst>
         </p14:section>
-        <p14:section name="Status" id="{25987693-b363-0b71-92b6-4c58034b6056}">
+        <p14:section name="Status" id="{eab79ff7-5946-e511-3378-75424f31759a}">
           <p14:sldIdLst>
             <p14:sldId id="264"/>
             <p14:sldId id="265"/>
@@ -9545,7 +9545,7 @@
                 <a:ea typeface="Cambria" pitchFamily="34" charset="-122"/>
                 <a:cs typeface="Cambria" pitchFamily="34" charset="-120"/>
               </a:rPr>
-              <a:t>2 / 2</a:t>
+              <a:t>3 / 3</a:t>
             </a:r>
             <a:endParaRPr lang="en-US" sz="4400" dirty="0"/>
           </a:p>
@@ -9617,7 +9617,7 @@
                   <a:schemeClr val="tx2"/>
                 </a:solidFill>
               </a:rPr>
-              <a:t>01_assign, 02_if</a:t>
+              <a:t>assign, if, syntax error</a:t>
             </a:r>
             <a:endParaRPr lang="en-US" sz="1200" dirty="0"/>
           </a:p>

</xml_diff>

<commit_message>
Add team member names to Review 1 slides
</commit_message>
<xml_diff>
--- a/docs/review1.pptx
+++ b/docs/review1.pptx
@@ -116,27 +116,27 @@
   <p:extLst>
     <p:ext uri="{521415D9-36F7-43E2-AB2F-B90AF26B5E84}">
       <p14:sectionLst xmlns:p14="http://schemas.microsoft.com/office/powerpoint/2010/main">
-        <p14:section name="Introduction" id="{4418caf4-680b-6024-b35b-1ed633ae5d1d}">
+        <p14:section name="Introduction" id="{1603f88e-455a-61a4-6421-ab2ded099406}">
           <p14:sldIdLst>
             <p14:sldId id="256"/>
             <p14:sldId id="257"/>
             <p14:sldId id="258"/>
           </p14:sldIdLst>
         </p14:section>
-        <p14:section name="Background" id="{290c39b4-51f5-fac6-41a9-86b1ed4e917b}">
+        <p14:section name="Background" id="{f258e84e-719d-7f45-09f7-744144ee5892}">
           <p14:sldIdLst>
             <p14:sldId id="259"/>
             <p14:sldId id="260"/>
           </p14:sldIdLst>
         </p14:section>
-        <p14:section name="Design" id="{c801d24d-d741-0486-2670-2d2e307ef3e3}">
+        <p14:section name="Design" id="{afe207be-bc1b-19eb-f56b-5432ce739a3e}">
           <p14:sldIdLst>
             <p14:sldId id="261"/>
             <p14:sldId id="262"/>
             <p14:sldId id="263"/>
           </p14:sldIdLst>
         </p14:section>
-        <p14:section name="Status" id="{eab79ff7-5946-e511-3378-75424f31759a}">
+        <p14:section name="Status" id="{ada26436-a339-3a45-fb0d-52557b59cbed}">
           <p14:sldIdLst>
             <p14:sldId id="264"/>
             <p14:sldId id="265"/>
@@ -2184,7 +2184,7 @@
                   <a:schemeClr val="bg1"/>
                 </a:solidFill>
               </a:rPr>
-              <a:t>[Member 2 name  ·  Reg. No.]</a:t>
+              <a:t>Jai Narayan Jayaprakash Jayanthi  ·  24BCE2751</a:t>
             </a:r>
             <a:endParaRPr lang="en-US" sz="1800" dirty="0"/>
           </a:p>
@@ -2201,7 +2201,7 @@
                   <a:schemeClr val="bg1"/>
                 </a:solidFill>
               </a:rPr>
-              <a:t>[Member 3 name  ·  Reg. No.]</a:t>
+              <a:t>Divyanshu Pal  ·  24BCE2856</a:t>
             </a:r>
             <a:endParaRPr lang="en-US" sz="1800" dirty="0"/>
           </a:p>
@@ -2237,7 +2237,7 @@
                   <a:srgbClr val="AEB8C6"/>
                 </a:solidFill>
               </a:rPr>
-              <a:t>BCSE307P Compiler Design Lab  ·  Review 1  ·  9 October 2026</a:t>
+              <a:t>Team 15  ·  BCSE307P Compiler Design Lab  ·  Review 1  ·  9 October 2026</a:t>
             </a:r>
             <a:endParaRPr lang="en-US" sz="1400" dirty="0"/>
           </a:p>

</xml_diff>

<commit_message>
Merge the generator into lexer.l and parser.y
</commit_message>
<xml_diff>
--- a/docs/review1.pptx
+++ b/docs/review1.pptx
@@ -116,27 +116,27 @@
   <p:extLst>
     <p:ext uri="{521415D9-36F7-43E2-AB2F-B90AF26B5E84}">
       <p14:sectionLst xmlns:p14="http://schemas.microsoft.com/office/powerpoint/2010/main">
-        <p14:section name="Introduction" id="{1603f88e-455a-61a4-6421-ab2ded099406}">
+        <p14:section name="Introduction" id="{bddb3cca-c95d-aa7d-d612-95e43aa30c96}">
           <p14:sldIdLst>
             <p14:sldId id="256"/>
             <p14:sldId id="257"/>
             <p14:sldId id="258"/>
           </p14:sldIdLst>
         </p14:section>
-        <p14:section name="Background" id="{f258e84e-719d-7f45-09f7-744144ee5892}">
+        <p14:section name="Background" id="{96ab2775-b67d-eb43-8dec-95acc917d134}">
           <p14:sldIdLst>
             <p14:sldId id="259"/>
             <p14:sldId id="260"/>
           </p14:sldIdLst>
         </p14:section>
-        <p14:section name="Design" id="{afe207be-bc1b-19eb-f56b-5432ce739a3e}">
+        <p14:section name="Design" id="{1c2d3b0b-be3a-6aad-4bfe-7c510c20a089}">
           <p14:sldIdLst>
             <p14:sldId id="261"/>
             <p14:sldId id="262"/>
             <p14:sldId id="263"/>
           </p14:sldIdLst>
         </p14:section>
-        <p14:section name="Status" id="{ada26436-a339-3a45-fb0d-52557b59cbed}">
+        <p14:section name="Status" id="{e0df762a-2dce-3e27-8824-3fd3f2645fac}">
           <p14:sldIdLst>
             <p14:sldId id="264"/>
             <p14:sldId id="265"/>
@@ -1256,7 +1256,7 @@
           <a:p>
             <a:r>
               <a:rPr lang="en-US" dirty="0"/>
-              <a:t>Each structure lives in its own file so individual contributions are easy to show. backpatch() refuses to fill a quad that is not an unfilled jump, which catches wrong semantic actions immediately.</a:t>
+              <a:t>The project is two files: lexer.l and parser.y. All five structures live in parser.y, below the grammar. backpatch() refuses to fill a quad that is not an unfilled jump, which catches wrong semantic actions immediately.</a:t>
             </a:r>
             <a:endParaRPr lang="en-US" dirty="0"/>
           </a:p>
@@ -6921,7 +6921,7 @@
                   <a:schemeClr val="tx2"/>
                 </a:solidFill>
               </a:rPr>
-              <a:t>main.c</a:t>
+              <a:t>--format=tac | quad</a:t>
             </a:r>
             <a:endParaRPr lang="en-US" sz="1400" dirty="0"/>
           </a:p>
@@ -7121,7 +7121,7 @@
                   <a:schemeClr val="tx2"/>
                 </a:solidFill>
               </a:rPr>
-              <a:t>symtab.c</a:t>
+              <a:t>symtab_insert()</a:t>
             </a:r>
             <a:endParaRPr lang="en-US" sz="1400" dirty="0"/>
           </a:p>
@@ -7135,7 +7135,7 @@
                   <a:schemeClr val="tx2"/>
                 </a:solidFill>
               </a:rPr>
-              <a:t>lookup / insert</a:t>
+              <a:t>in parser.y</a:t>
             </a:r>
             <a:endParaRPr lang="en-US" sz="1400" dirty="0"/>
           </a:p>
@@ -7253,7 +7253,7 @@
                   <a:schemeClr val="tx2"/>
                 </a:solidFill>
               </a:rPr>
-              <a:t>quad.c</a:t>
+              <a:t>emit(), newtemp()</a:t>
             </a:r>
             <a:endParaRPr lang="en-US" sz="1400" dirty="0"/>
           </a:p>
@@ -7267,7 +7267,7 @@
                   <a:schemeClr val="tx2"/>
                 </a:solidFill>
               </a:rPr>
-              <a:t>emit(), newtemp()</a:t>
+              <a:t>in parser.y</a:t>
             </a:r>
             <a:endParaRPr lang="en-US" sz="1400" dirty="0"/>
           </a:p>
@@ -7385,7 +7385,7 @@
                   <a:schemeClr val="tx1"/>
                 </a:solidFill>
               </a:rPr>
-              <a:t>backpatch.c</a:t>
+              <a:t>makelist, merge, backpatch</a:t>
             </a:r>
             <a:endParaRPr lang="en-US" sz="1400" dirty="0"/>
           </a:p>
@@ -7399,7 +7399,7 @@
                   <a:schemeClr val="tx1"/>
                 </a:solidFill>
               </a:rPr>
-              <a:t>makelist, merge, backpatch</a:t>
+              <a:t>in parser.y</a:t>
             </a:r>
             <a:endParaRPr lang="en-US" sz="1400" dirty="0"/>
           </a:p>
@@ -8203,9 +8203,9 @@
             <a:tbl>
               <a:tblPr/>
               <a:tblGrid>
-                <a:gridCol w="1737360"/>
-                <a:gridCol w="3657600"/>
-                <a:gridCol w="1554480"/>
+                <a:gridCol w="1645920"/>
+                <a:gridCol w="3108960"/>
+                <a:gridCol w="2194560"/>
               </a:tblGrid>
               <a:tr h="713232">
                 <a:tc>
@@ -8296,7 +8296,7 @@
                             <a:schemeClr val="bg1"/>
                           </a:solidFill>
                         </a:rPr>
-                        <a:t>Module</a:t>
+                        <a:t>Functions</a:t>
                       </a:r>
                       <a:endParaRPr lang="en-US" sz="1400" dirty="0"/>
                     </a:p>
@@ -8412,7 +8412,7 @@
                           <a:ea typeface="Courier New" pitchFamily="34" charset="-122"/>
                           <a:cs typeface="Courier New" pitchFamily="34" charset="-120"/>
                         </a:rPr>
-                        <a:t>quad.c</a:t>
+                        <a:t>emit()</a:t>
                       </a:r>
                       <a:endParaRPr lang="en-US" sz="1400" dirty="0">
                         <a:latin typeface="Courier New" charset="0"/>
@@ -8532,7 +8532,7 @@
                           <a:ea typeface="Courier New" pitchFamily="34" charset="-122"/>
                           <a:cs typeface="Courier New" pitchFamily="34" charset="-120"/>
                         </a:rPr>
-                        <a:t>quad.c</a:t>
+                        <a:t>print_tac()</a:t>
                       </a:r>
                       <a:endParaRPr lang="en-US" sz="1400" dirty="0">
                         <a:latin typeface="Courier New" charset="0"/>
@@ -8652,7 +8652,7 @@
                           <a:ea typeface="Courier New" pitchFamily="34" charset="-122"/>
                           <a:cs typeface="Courier New" pitchFamily="34" charset="-120"/>
                         </a:rPr>
-                        <a:t>backpatch.c</a:t>
+                        <a:t>makelist, merge, backpatch</a:t>
                       </a:r>
                       <a:endParaRPr lang="en-US" sz="1400" dirty="0">
                         <a:latin typeface="Courier New" charset="0"/>
@@ -8732,7 +8732,7 @@
                             <a:schemeClr val="tx1"/>
                           </a:solidFill>
                         </a:rPr>
-                        <a:t>name, type, first-seen line</a:t>
+                        <a:t>name, first-seen line (type is int)</a:t>
                       </a:r>
                       <a:endParaRPr lang="en-US" sz="1400" dirty="0"/>
                     </a:p>
@@ -8772,7 +8772,7 @@
                           <a:ea typeface="Courier New" pitchFamily="34" charset="-122"/>
                           <a:cs typeface="Courier New" pitchFamily="34" charset="-120"/>
                         </a:rPr>
-                        <a:t>symtab.c</a:t>
+                        <a:t>symtab_insert()</a:t>
                       </a:r>
                       <a:endParaRPr lang="en-US" sz="1400" dirty="0">
                         <a:latin typeface="Courier New" charset="0"/>
@@ -8852,7 +8852,7 @@
                             <a:schemeClr val="tx1"/>
                           </a:solidFill>
                         </a:rPr>
-                        <a:t>newtemp() returns t1, t2, ...</a:t>
+                        <a:t>returns t1, t2, ...</a:t>
                       </a:r>
                       <a:endParaRPr lang="en-US" sz="1400" dirty="0"/>
                     </a:p>
@@ -8892,7 +8892,7 @@
                           <a:ea typeface="Courier New" pitchFamily="34" charset="-122"/>
                           <a:cs typeface="Courier New" pitchFamily="34" charset="-120"/>
                         </a:rPr>
-                        <a:t>quad.c</a:t>
+                        <a:t>newtemp()</a:t>
                       </a:r>
                       <a:endParaRPr lang="en-US" sz="1400" dirty="0">
                         <a:latin typeface="Courier New" charset="0"/>
@@ -9625,7 +9625,7 @@
       </p:sp>
       <p:sp>
         <p:nvSpPr>
-          <p:cNvPr id="11" name="stat unit checks pass"/>
+          <p:cNvPr id="11" name="stat source files"/>
           <p:cNvSpPr/>
           <p:nvPr/>
         </p:nvSpPr>
@@ -9678,7 +9678,7 @@
                 <a:ea typeface="Cambria" pitchFamily="34" charset="-122"/>
                 <a:cs typeface="Cambria" pitchFamily="34" charset="-120"/>
               </a:rPr>
-              <a:t>6 / 6</a:t>
+              <a:t>2</a:t>
             </a:r>
             <a:endParaRPr lang="en-US" sz="4400" dirty="0"/>
           </a:p>
@@ -9714,7 +9714,7 @@
                   <a:schemeClr val="tx1"/>
                 </a:solidFill>
               </a:rPr>
-              <a:t>unit checks pass</a:t>
+              <a:t>source files</a:t>
             </a:r>
             <a:endParaRPr lang="en-US" sz="1600" dirty="0"/>
           </a:p>
@@ -9750,7 +9750,7 @@
                   <a:schemeClr val="tx2"/>
                 </a:solidFill>
               </a:rPr>
-              <a:t>makelist, merge, backpatch</a:t>
+              <a:t>lexer.l and parser.y</a:t>
             </a:r>
             <a:endParaRPr lang="en-US" sz="1200" dirty="0"/>
           </a:p>

</xml_diff>